<commit_message>
docs: enrich executive PPTs with mermaid graphics from v01-executive-one-pager
</commit_message>
<xml_diff>
--- a/reference/governance/sdlc/assets/evolith-sdlc-executive-deck.pptx
+++ b/reference/governance/sdlc/assets/evolith-sdlc-executive-deck.pptx
@@ -3215,7 +3215,11 @@
             <p:ph idx="1"/>
           </p:nvPr>
         </p:nvSpPr>
-        <p:spPr/>
+        <p:spPr>
+          <a:xfrm>
+            <a:ext cx="4114800" cy="0"/>
+          </a:xfrm>
+        </p:spPr>
         <p:txBody>
           <a:bodyPr/>
           <a:lstStyle/>
@@ -3262,6 +3266,30 @@
           </a:p>
         </p:txBody>
       </p:sp>
+      <p:pic>
+        <p:nvPicPr>
+          <p:cNvPr id="4" name="Picture 3" descr="visual_1_A.png"/>
+          <p:cNvPicPr>
+            <a:picLocks noChangeAspect="1"/>
+          </p:cNvPicPr>
+          <p:nvPr/>
+        </p:nvPicPr>
+        <p:blipFill>
+          <a:blip r:embed="rId2"/>
+          <a:stretch>
+            <a:fillRect/>
+          </a:stretch>
+        </p:blipFill>
+        <p:spPr>
+          <a:xfrm>
+            <a:off x="4572000" y="-695946"/>
+            <a:ext cx="4114800" cy="9164293"/>
+          </a:xfrm>
+          <a:prstGeom prst="rect">
+            <a:avLst/>
+          </a:prstGeom>
+        </p:spPr>
+      </p:pic>
     </p:spTree>
   </p:cSld>
   <p:clrMapOvr>
@@ -3318,7 +3346,11 @@
             <p:ph idx="1"/>
           </p:nvPr>
         </p:nvSpPr>
-        <p:spPr/>
+        <p:spPr>
+          <a:xfrm>
+            <a:ext cx="4114800" cy="0"/>
+          </a:xfrm>
+        </p:spPr>
         <p:txBody>
           <a:bodyPr/>
           <a:lstStyle/>
@@ -3365,6 +3397,30 @@
           </a:p>
         </p:txBody>
       </p:sp>
+      <p:pic>
+        <p:nvPicPr>
+          <p:cNvPr id="4" name="Picture 3" descr="visual_1_B.png"/>
+          <p:cNvPicPr>
+            <a:picLocks noChangeAspect="1"/>
+          </p:cNvPicPr>
+          <p:nvPr/>
+        </p:nvPicPr>
+        <p:blipFill>
+          <a:blip r:embed="rId2"/>
+          <a:stretch>
+            <a:fillRect/>
+          </a:stretch>
+        </p:blipFill>
+        <p:spPr>
+          <a:xfrm>
+            <a:off x="4572000" y="3098929"/>
+            <a:ext cx="4114800" cy="1574541"/>
+          </a:xfrm>
+          <a:prstGeom prst="rect">
+            <a:avLst/>
+          </a:prstGeom>
+        </p:spPr>
+      </p:pic>
     </p:spTree>
   </p:cSld>
   <p:clrMapOvr>
@@ -3421,7 +3477,11 @@
             <p:ph idx="1"/>
           </p:nvPr>
         </p:nvSpPr>
-        <p:spPr/>
+        <p:spPr>
+          <a:xfrm>
+            <a:ext cx="4114800" cy="0"/>
+          </a:xfrm>
+        </p:spPr>
         <p:txBody>
           <a:bodyPr/>
           <a:lstStyle/>
@@ -3490,6 +3550,30 @@
           </a:p>
         </p:txBody>
       </p:sp>
+      <p:pic>
+        <p:nvPicPr>
+          <p:cNvPr id="4" name="Picture 3" descr="visual_1_C.png"/>
+          <p:cNvPicPr>
+            <a:picLocks noChangeAspect="1"/>
+          </p:cNvPicPr>
+          <p:nvPr/>
+        </p:nvPicPr>
+        <p:blipFill>
+          <a:blip r:embed="rId2"/>
+          <a:stretch>
+            <a:fillRect/>
+          </a:stretch>
+        </p:blipFill>
+        <p:spPr>
+          <a:xfrm>
+            <a:off x="4572000" y="2728912"/>
+            <a:ext cx="4114800" cy="2314575"/>
+          </a:xfrm>
+          <a:prstGeom prst="rect">
+            <a:avLst/>
+          </a:prstGeom>
+        </p:spPr>
+      </p:pic>
     </p:spTree>
   </p:cSld>
   <p:clrMapOvr>
@@ -3877,7 +3961,11 @@
             <p:ph idx="1"/>
           </p:nvPr>
         </p:nvSpPr>
-        <p:spPr/>
+        <p:spPr>
+          <a:xfrm>
+            <a:ext cx="4114800" cy="0"/>
+          </a:xfrm>
+        </p:spPr>
         <p:txBody>
           <a:bodyPr/>
           <a:lstStyle/>
@@ -3935,6 +4023,30 @@
           </a:p>
         </p:txBody>
       </p:sp>
+      <p:pic>
+        <p:nvPicPr>
+          <p:cNvPr id="4" name="Picture 3" descr="visual_1_D.png"/>
+          <p:cNvPicPr>
+            <a:picLocks noChangeAspect="1"/>
+          </p:cNvPicPr>
+          <p:nvPr/>
+        </p:nvPicPr>
+        <p:blipFill>
+          <a:blip r:embed="rId2"/>
+          <a:stretch>
+            <a:fillRect/>
+          </a:stretch>
+        </p:blipFill>
+        <p:spPr>
+          <a:xfrm>
+            <a:off x="4572000" y="2881118"/>
+            <a:ext cx="4114800" cy="2010164"/>
+          </a:xfrm>
+          <a:prstGeom prst="rect">
+            <a:avLst/>
+          </a:prstGeom>
+        </p:spPr>
+      </p:pic>
     </p:spTree>
   </p:cSld>
   <p:clrMapOvr>

</xml_diff>

<commit_message>
docs: upgrade executive artifacts to pro level with excel workbooks and tailored mermaid charts
</commit_message>
<xml_diff>
--- a/reference/governance/sdlc/assets/evolith-sdlc-executive-deck.pptx
+++ b/reference/governance/sdlc/assets/evolith-sdlc-executive-deck.pptx
@@ -3119,7 +3119,7 @@
           <a:lstStyle/>
           <a:p>
             <a:pPr>
-              <a:defRPr b="1" sz="4400">
+              <a:defRPr b="1">
                 <a:solidFill>
                   <a:srgbClr val="FFFFFF"/>
                 </a:solidFill>
@@ -3147,7 +3147,7 @@
           <a:lstStyle/>
           <a:p>
             <a:pPr>
-              <a:defRPr sz="2400">
+              <a:defRPr>
                 <a:solidFill>
                   <a:srgbClr val="3B82F6"/>
                 </a:solidFill>
@@ -3193,7 +3193,7 @@
           <a:lstStyle/>
           <a:p>
             <a:pPr>
-              <a:defRPr b="1" sz="3600">
+              <a:defRPr>
                 <a:solidFill>
                   <a:srgbClr val="1E3A5F"/>
                 </a:solidFill>
@@ -3217,7 +3217,7 @@
         </p:nvSpPr>
         <p:spPr>
           <a:xfrm>
-            <a:ext cx="4114800" cy="0"/>
+            <a:ext cx="3840480" cy="0"/>
           </a:xfrm>
         </p:spPr>
         <p:txBody>
@@ -3225,50 +3225,39 @@
           <a:lstStyle/>
           <a:p>
             <a:pPr>
-              <a:defRPr sz="2000"/>
+              <a:defRPr sz="1800"/>
             </a:pPr>
             <a:r>
-              <a:t>Framework corporativo y arquitectura base de referencia.</a:t>
+              <a:t>Framework corporativo y arquitectura base.</a:t>
             </a:r>
           </a:p>
           <a:p>
             <a:pPr>
               <a:spcBef>
-                <a:spcPts val="1000"/>
+                <a:spcPts val="800"/>
               </a:spcBef>
-              <a:defRPr sz="2000"/>
+              <a:defRPr sz="1800"/>
             </a:pPr>
             <a:r>
-              <a:t>Provee patrones, estándares y gobierno unificado.</a:t>
+              <a:t>Estandariza patrones entre equipos.</a:t>
             </a:r>
           </a:p>
           <a:p>
             <a:pPr>
               <a:spcBef>
-                <a:spcPts val="1000"/>
+                <a:spcPts val="800"/>
               </a:spcBef>
-              <a:defRPr sz="2000"/>
+              <a:defRPr sz="1800"/>
             </a:pPr>
             <a:r>
-              <a:t>Asegura consistencia en todo el portafolio de aplicaciones.</a:t>
-            </a:r>
-          </a:p>
-          <a:p>
-            <a:pPr>
-              <a:spcBef>
-                <a:spcPts val="1000"/>
-              </a:spcBef>
-              <a:defRPr sz="2000"/>
-            </a:pPr>
-            <a:r>
-              <a:t>Facilita la evolución desde monolitos simples a microservicios distribuidos.</a:t>
+              <a:t>No es una app, es el modelo operativo.</a:t>
             </a:r>
           </a:p>
         </p:txBody>
       </p:sp>
       <p:pic>
         <p:nvPicPr>
-          <p:cNvPr id="4" name="Picture 3" descr="visual_1_A.png"/>
+          <p:cNvPr id="4" name="Picture 3" descr="ppt1_slide1.png"/>
           <p:cNvPicPr>
             <a:picLocks noChangeAspect="1"/>
           </p:cNvPicPr>
@@ -3282,8 +3271,8 @@
         </p:blipFill>
         <p:spPr>
           <a:xfrm>
-            <a:off x="4572000" y="-695946"/>
-            <a:ext cx="4114800" cy="9164293"/>
+            <a:off x="4114800" y="3343548"/>
+            <a:ext cx="4572000" cy="1085304"/>
           </a:xfrm>
           <a:prstGeom prst="rect">
             <a:avLst/>
@@ -3324,7 +3313,7 @@
           <a:lstStyle/>
           <a:p>
             <a:pPr>
-              <a:defRPr b="1" sz="3600">
+              <a:defRPr>
                 <a:solidFill>
                   <a:srgbClr val="1E3A5F"/>
                 </a:solidFill>
@@ -3348,7 +3337,7 @@
         </p:nvSpPr>
         <p:spPr>
           <a:xfrm>
-            <a:ext cx="4114800" cy="0"/>
+            <a:ext cx="3840480" cy="0"/>
           </a:xfrm>
         </p:spPr>
         <p:txBody>
@@ -3356,50 +3345,39 @@
           <a:lstStyle/>
           <a:p>
             <a:pPr>
-              <a:defRPr sz="2000"/>
+              <a:defRPr sz="1800"/>
             </a:pPr>
             <a:r>
-              <a:t>Evita la fragmentación tecnológica entre equipos.</a:t>
+              <a:t>Elimina zonas grises y deuda técnica silenciosa.</a:t>
             </a:r>
           </a:p>
           <a:p>
             <a:pPr>
               <a:spcBef>
-                <a:spcPts val="1000"/>
+                <a:spcPts val="800"/>
               </a:spcBef>
-              <a:defRPr sz="2000"/>
+              <a:defRPr sz="1800"/>
             </a:pPr>
             <a:r>
-              <a:t>Reduce el riesgo arquitectónico (decisiones tempranas vs tardías).</a:t>
+              <a:t>Previene arquitectura fragmentada.</a:t>
             </a:r>
           </a:p>
           <a:p>
             <a:pPr>
               <a:spcBef>
-                <a:spcPts val="1000"/>
+                <a:spcPts val="800"/>
               </a:spcBef>
-              <a:defRPr sz="2000"/>
+              <a:defRPr sz="1800"/>
             </a:pPr>
             <a:r>
-              <a:t>Alinea el trabajo de ingeniería con el gobierno SDLC.</a:t>
-            </a:r>
-          </a:p>
-          <a:p>
-            <a:pPr>
-              <a:spcBef>
-                <a:spcPts val="1000"/>
-              </a:spcBef>
-              <a:defRPr sz="2000"/>
-            </a:pPr>
-            <a:r>
-              <a:t>Elimina las 'zonas grises' de responsabilidad y calidad.</a:t>
+              <a:t>Reduce el riesgo de delivery.</a:t>
             </a:r>
           </a:p>
         </p:txBody>
       </p:sp>
       <p:pic>
         <p:nvPicPr>
-          <p:cNvPr id="4" name="Picture 3" descr="visual_1_B.png"/>
+          <p:cNvPr id="4" name="Picture 3" descr="ppt1_slide2.png"/>
           <p:cNvPicPr>
             <a:picLocks noChangeAspect="1"/>
           </p:cNvPicPr>
@@ -3413,8 +3391,8 @@
         </p:blipFill>
         <p:spPr>
           <a:xfrm>
-            <a:off x="4572000" y="3098929"/>
-            <a:ext cx="4114800" cy="1574541"/>
+            <a:off x="4114800" y="3168214"/>
+            <a:ext cx="4572000" cy="1435971"/>
           </a:xfrm>
           <a:prstGeom prst="rect">
             <a:avLst/>
@@ -3455,14 +3433,14 @@
           <a:lstStyle/>
           <a:p>
             <a:pPr>
-              <a:defRPr b="1" sz="3600">
+              <a:defRPr>
                 <a:solidFill>
                   <a:srgbClr val="1E3A5F"/>
                 </a:solidFill>
               </a:defRPr>
             </a:pPr>
             <a:r>
-              <a:t>3. Evolith y el SDLC</a:t>
+              <a:t>3. El SDLC de Evolith</a:t>
             </a:r>
           </a:p>
         </p:txBody>
@@ -3479,7 +3457,7 @@
         </p:nvSpPr>
         <p:spPr>
           <a:xfrm>
-            <a:ext cx="4114800" cy="0"/>
+            <a:ext cx="3840480" cy="0"/>
           </a:xfrm>
         </p:spPr>
         <p:txBody>
@@ -3487,72 +3465,39 @@
           <a:lstStyle/>
           <a:p>
             <a:pPr>
-              <a:defRPr sz="2000"/>
+              <a:defRPr sz="1800"/>
             </a:pPr>
             <a:r>
-              <a:t>Evolith provee la estructura; el SDLC provee el ciclo de vida.</a:t>
+              <a:t>Evolith provee la estructura; SDLC el ciclo de vida.</a:t>
             </a:r>
           </a:p>
           <a:p>
             <a:pPr>
               <a:spcBef>
-                <a:spcPts val="1000"/>
+                <a:spcPts val="800"/>
               </a:spcBef>
-              <a:defRPr sz="2000"/>
+              <a:defRPr sz="1800"/>
             </a:pPr>
             <a:r>
-              <a:t>Fase 1: Concepción (PRD, Viabilidad).</a:t>
+              <a:t>Consta de 5 Fases gobernadas.</a:t>
             </a:r>
           </a:p>
           <a:p>
             <a:pPr>
               <a:spcBef>
-                <a:spcPts val="1000"/>
+                <a:spcPts val="800"/>
               </a:spcBef>
-              <a:defRPr sz="2000"/>
+              <a:defRPr sz="1800"/>
             </a:pPr>
             <a:r>
-              <a:t>Fase 2: Diseño (ADR, Historias Funcionales).</a:t>
-            </a:r>
-          </a:p>
-          <a:p>
-            <a:pPr>
-              <a:spcBef>
-                <a:spcPts val="1000"/>
-              </a:spcBef>
-              <a:defRPr sz="2000"/>
-            </a:pPr>
-            <a:r>
-              <a:t>Fase 3: Construcción (Historias Técnicas).</a:t>
-            </a:r>
-          </a:p>
-          <a:p>
-            <a:pPr>
-              <a:spcBef>
-                <a:spcPts val="1000"/>
-              </a:spcBef>
-              <a:defRPr sz="2000"/>
-            </a:pPr>
-            <a:r>
-              <a:t>Fase 4: Validación (Test Summary Report).</a:t>
-            </a:r>
-          </a:p>
-          <a:p>
-            <a:pPr>
-              <a:spcBef>
-                <a:spcPts val="1000"/>
-              </a:spcBef>
-              <a:defRPr sz="2000"/>
-            </a:pPr>
-            <a:r>
-              <a:t>Fase 5: Entrega (Release Notes).</a:t>
+              <a:t>Progreso condicionado a evidencia.</a:t>
             </a:r>
           </a:p>
         </p:txBody>
       </p:sp>
       <p:pic>
         <p:nvPicPr>
-          <p:cNvPr id="4" name="Picture 3" descr="visual_1_C.png"/>
+          <p:cNvPr id="4" name="Picture 3" descr="ppt1_slide3.png"/>
           <p:cNvPicPr>
             <a:picLocks noChangeAspect="1"/>
           </p:cNvPicPr>
@@ -3566,8 +3511,8 @@
         </p:blipFill>
         <p:spPr>
           <a:xfrm>
-            <a:off x="4572000" y="2728912"/>
-            <a:ext cx="4114800" cy="2314575"/>
+            <a:off x="4114800" y="3717082"/>
+            <a:ext cx="4572000" cy="338235"/>
           </a:xfrm>
           <a:prstGeom prst="rect">
             <a:avLst/>
@@ -3608,7 +3553,7 @@
           <a:lstStyle/>
           <a:p>
             <a:pPr>
-              <a:defRPr b="1" sz="3600">
+              <a:defRPr>
                 <a:solidFill>
                   <a:srgbClr val="1E3A5F"/>
                 </a:solidFill>
@@ -3630,64 +3575,70 @@
             <p:ph idx="1"/>
           </p:nvPr>
         </p:nvSpPr>
-        <p:spPr/>
+        <p:spPr>
+          <a:xfrm>
+            <a:ext cx="3840480" cy="0"/>
+          </a:xfrm>
+        </p:spPr>
         <p:txBody>
           <a:bodyPr/>
           <a:lstStyle/>
           <a:p>
             <a:pPr>
-              <a:defRPr sz="2000"/>
+              <a:defRPr sz="1800"/>
             </a:pPr>
             <a:r>
-              <a:t>Concepción: PRD (Product Requirements Document).</a:t>
+              <a:t>Cada fase exige documentación específica.</a:t>
             </a:r>
           </a:p>
           <a:p>
             <a:pPr>
               <a:spcBef>
-                <a:spcPts val="1000"/>
+                <a:spcPts val="800"/>
               </a:spcBef>
-              <a:defRPr sz="2000"/>
+              <a:defRPr sz="1800"/>
             </a:pPr>
             <a:r>
-              <a:t>Diseño: ADR (Registro de Decisión Arquitectónica), Historias Funcionales.</a:t>
+              <a:t>Desde el PRD funcional hasta las notas de release.</a:t>
             </a:r>
           </a:p>
           <a:p>
             <a:pPr>
               <a:spcBef>
-                <a:spcPts val="1000"/>
+                <a:spcPts val="800"/>
               </a:spcBef>
-              <a:defRPr sz="2000"/>
+              <a:defRPr sz="1800"/>
             </a:pPr>
             <a:r>
-              <a:t>Construcción: Historias Técnicas, Pruebas Unitarias/Integración.</a:t>
-            </a:r>
-          </a:p>
-          <a:p>
-            <a:pPr>
-              <a:spcBef>
-                <a:spcPts val="1000"/>
-              </a:spcBef>
-              <a:defRPr sz="2000"/>
-            </a:pPr>
-            <a:r>
-              <a:t>Validación: Test Summary Report, Evidencia de Quality Gates.</a:t>
-            </a:r>
-          </a:p>
-          <a:p>
-            <a:pPr>
-              <a:spcBef>
-                <a:spcPts val="1000"/>
-              </a:spcBef>
-              <a:defRPr sz="2000"/>
-            </a:pPr>
-            <a:r>
-              <a:t>Entrega: Release Notes, Checklist de Observabilidad.</a:t>
-            </a:r>
-          </a:p>
-        </p:txBody>
-      </p:sp>
+              <a:t>Sin artefacto no hay avance.</a:t>
+            </a:r>
+          </a:p>
+        </p:txBody>
+      </p:sp>
+      <p:pic>
+        <p:nvPicPr>
+          <p:cNvPr id="4" name="Picture 3" descr="ppt1_slide4.png"/>
+          <p:cNvPicPr>
+            <a:picLocks noChangeAspect="1"/>
+          </p:cNvPicPr>
+          <p:nvPr/>
+        </p:nvPicPr>
+        <p:blipFill>
+          <a:blip r:embed="rId2"/>
+          <a:stretch>
+            <a:fillRect/>
+          </a:stretch>
+        </p:blipFill>
+        <p:spPr>
+          <a:xfrm>
+            <a:off x="4114800" y="2418767"/>
+            <a:ext cx="4572000" cy="2934865"/>
+          </a:xfrm>
+          <a:prstGeom prst="rect">
+            <a:avLst/>
+          </a:prstGeom>
+        </p:spPr>
+      </p:pic>
     </p:spTree>
   </p:cSld>
   <p:clrMapOvr>
@@ -3722,7 +3673,7 @@
           <a:lstStyle/>
           <a:p>
             <a:pPr>
-              <a:defRPr b="1" sz="3600">
+              <a:defRPr>
                 <a:solidFill>
                   <a:srgbClr val="1E3A5F"/>
                 </a:solidFill>
@@ -3744,64 +3695,70 @@
             <p:ph idx="1"/>
           </p:nvPr>
         </p:nvSpPr>
-        <p:spPr/>
+        <p:spPr>
+          <a:xfrm>
+            <a:ext cx="3840480" cy="0"/>
+          </a:xfrm>
+        </p:spPr>
         <p:txBody>
           <a:bodyPr/>
           <a:lstStyle/>
           <a:p>
             <a:pPr>
-              <a:defRPr sz="2000"/>
+              <a:defRPr sz="1800"/>
             </a:pPr>
             <a:r>
-              <a:t>Product Owner: Define el QUÉ (PRD, Historias Funcionales).</a:t>
+              <a:t>Responsabilidades claras (RACI).</a:t>
             </a:r>
           </a:p>
           <a:p>
             <a:pPr>
               <a:spcBef>
-                <a:spcPts val="1000"/>
+                <a:spcPts val="800"/>
               </a:spcBef>
-              <a:defRPr sz="2000"/>
+              <a:defRPr sz="1800"/>
             </a:pPr>
             <a:r>
-              <a:t>Arquitecto: Define el CÓMO a alto nivel (ADR, Patrones).</a:t>
+              <a:t>Product Owner define QUÉ.</a:t>
             </a:r>
           </a:p>
           <a:p>
             <a:pPr>
               <a:spcBef>
-                <a:spcPts val="1000"/>
+                <a:spcPts val="800"/>
               </a:spcBef>
-              <a:defRPr sz="2000"/>
+              <a:defRPr sz="1800"/>
             </a:pPr>
             <a:r>
-              <a:t>Tech Lead: Guía el CÓMO técnico y asegura el Definition of Done.</a:t>
-            </a:r>
-          </a:p>
-          <a:p>
-            <a:pPr>
-              <a:spcBef>
-                <a:spcPts val="1000"/>
-              </a:spcBef>
-              <a:defRPr sz="2000"/>
-            </a:pPr>
-            <a:r>
-              <a:t>QA/SDET: Valida el umbral de calidad (Quality Gates).</a:t>
-            </a:r>
-          </a:p>
-          <a:p>
-            <a:pPr>
-              <a:spcBef>
-                <a:spcPts val="1000"/>
-              </a:spcBef>
-              <a:defRPr sz="2000"/>
-            </a:pPr>
-            <a:r>
-              <a:t>DevOps/SRE: Ejecuta el pase a producción y asegura operabilidad.</a:t>
-            </a:r>
-          </a:p>
-        </p:txBody>
-      </p:sp>
+              <a:t>Arquitecto/Tech Lead define CÓMO.</a:t>
+            </a:r>
+          </a:p>
+        </p:txBody>
+      </p:sp>
+      <p:pic>
+        <p:nvPicPr>
+          <p:cNvPr id="4" name="Picture 3" descr="ppt1_slide5.png"/>
+          <p:cNvPicPr>
+            <a:picLocks noChangeAspect="1"/>
+          </p:cNvPicPr>
+          <p:nvPr/>
+        </p:nvPicPr>
+        <p:blipFill>
+          <a:blip r:embed="rId2"/>
+          <a:stretch>
+            <a:fillRect/>
+          </a:stretch>
+        </p:blipFill>
+        <p:spPr>
+          <a:xfrm>
+            <a:off x="4114800" y="3077935"/>
+            <a:ext cx="4572000" cy="1616529"/>
+          </a:xfrm>
+          <a:prstGeom prst="rect">
+            <a:avLst/>
+          </a:prstGeom>
+        </p:spPr>
+      </p:pic>
     </p:spTree>
   </p:cSld>
   <p:clrMapOvr>
@@ -3836,14 +3793,14 @@
           <a:lstStyle/>
           <a:p>
             <a:pPr>
-              <a:defRPr b="1" sz="3600">
+              <a:defRPr>
                 <a:solidFill>
                   <a:srgbClr val="1E3A5F"/>
                 </a:solidFill>
               </a:defRPr>
             </a:pPr>
             <a:r>
-              <a:t>6. Calidad, Trazabilidad y Decisiones</a:t>
+              <a:t>6. Quality Gates</a:t>
             </a:r>
           </a:p>
         </p:txBody>
@@ -3858,53 +3815,70 @@
             <p:ph idx="1"/>
           </p:nvPr>
         </p:nvSpPr>
-        <p:spPr/>
+        <p:spPr>
+          <a:xfrm>
+            <a:ext cx="3840480" cy="0"/>
+          </a:xfrm>
+        </p:spPr>
         <p:txBody>
           <a:bodyPr/>
           <a:lstStyle/>
           <a:p>
             <a:pPr>
-              <a:defRPr sz="2000"/>
+              <a:defRPr sz="1800"/>
             </a:pPr>
             <a:r>
-              <a:t>Traceability Model: Del PRD a Producción sin saltos.</a:t>
+              <a:t>Verificaciones automatizadas y objetivas.</a:t>
             </a:r>
           </a:p>
           <a:p>
             <a:pPr>
               <a:spcBef>
-                <a:spcPts val="1000"/>
+                <a:spcPts val="800"/>
               </a:spcBef>
-              <a:defRPr sz="2000"/>
+              <a:defRPr sz="1800"/>
             </a:pPr>
             <a:r>
-              <a:t>Quality Gates Objetivos: Cobertura, Complejidad, Seguridad, Deuda Técnica.</a:t>
+              <a:t>Se detiene el despliegue si falla cobertura o seguridad.</a:t>
             </a:r>
           </a:p>
           <a:p>
             <a:pPr>
               <a:spcBef>
-                <a:spcPts val="1000"/>
+                <a:spcPts val="800"/>
               </a:spcBef>
-              <a:defRPr sz="2000"/>
+              <a:defRPr sz="1800"/>
             </a:pPr>
             <a:r>
-              <a:t>Decision Records: Todo cambio estructural se documenta en un ADR.</a:t>
-            </a:r>
-          </a:p>
-          <a:p>
-            <a:pPr>
-              <a:spcBef>
-                <a:spcPts val="1000"/>
-              </a:spcBef>
-              <a:defRPr sz="2000"/>
-            </a:pPr>
-            <a:r>
-              <a:t>La evidencia es obligatoria; los acuerdos verbales no bastan.</a:t>
-            </a:r>
-          </a:p>
-        </p:txBody>
-      </p:sp>
+              <a:t>Asegura mantenibilidad a largo plazo.</a:t>
+            </a:r>
+          </a:p>
+        </p:txBody>
+      </p:sp>
+      <p:pic>
+        <p:nvPicPr>
+          <p:cNvPr id="4" name="Picture 3" descr="ppt1_slide6.png"/>
+          <p:cNvPicPr>
+            <a:picLocks noChangeAspect="1"/>
+          </p:cNvPicPr>
+          <p:nvPr/>
+        </p:nvPicPr>
+        <p:blipFill>
+          <a:blip r:embed="rId2"/>
+          <a:stretch>
+            <a:fillRect/>
+          </a:stretch>
+        </p:blipFill>
+        <p:spPr>
+          <a:xfrm>
+            <a:off x="4114800" y="1996944"/>
+            <a:ext cx="4572000" cy="3778512"/>
+          </a:xfrm>
+          <a:prstGeom prst="rect">
+            <a:avLst/>
+          </a:prstGeom>
+        </p:spPr>
+      </p:pic>
     </p:spTree>
   </p:cSld>
   <p:clrMapOvr>
@@ -3939,7 +3913,7 @@
           <a:lstStyle/>
           <a:p>
             <a:pPr>
-              <a:defRPr b="1" sz="3600">
+              <a:defRPr>
                 <a:solidFill>
                   <a:srgbClr val="1E3A5F"/>
                 </a:solidFill>
@@ -3963,7 +3937,7 @@
         </p:nvSpPr>
         <p:spPr>
           <a:xfrm>
-            <a:ext cx="4114800" cy="0"/>
+            <a:ext cx="3840480" cy="0"/>
           </a:xfrm>
         </p:spPr>
         <p:txBody>
@@ -3971,61 +3945,39 @@
           <a:lstStyle/>
           <a:p>
             <a:pPr>
-              <a:defRPr sz="2000"/>
+              <a:defRPr sz="1800"/>
             </a:pPr>
             <a:r>
-              <a:t>Negocio: Previsibilidad y control de la inversión.</a:t>
+              <a:t>Menor fricción entre Dev y Ops.</a:t>
             </a:r>
           </a:p>
           <a:p>
             <a:pPr>
               <a:spcBef>
-                <a:spcPts val="1000"/>
+                <a:spcPts val="800"/>
               </a:spcBef>
-              <a:defRPr sz="2000"/>
+              <a:defRPr sz="1800"/>
             </a:pPr>
             <a:r>
-              <a:t>Tecnología: Base de código sostenible y escalable.</a:t>
+              <a:t>Predicibilidad de negocio.</a:t>
             </a:r>
           </a:p>
           <a:p>
             <a:pPr>
               <a:spcBef>
-                <a:spcPts val="1000"/>
+                <a:spcPts val="800"/>
               </a:spcBef>
-              <a:defRPr sz="2000"/>
+              <a:defRPr sz="1800"/>
             </a:pPr>
             <a:r>
-              <a:t>Arquitectura: Decisiones documentadas y reutilizables.</a:t>
-            </a:r>
-          </a:p>
-          <a:p>
-            <a:pPr>
-              <a:spcBef>
-                <a:spcPts val="1000"/>
-              </a:spcBef>
-              <a:defRPr sz="2000"/>
-            </a:pPr>
-            <a:r>
-              <a:t>QA/DevOps: Criterios claros de entrada/salida y despliegues seguros.</a:t>
-            </a:r>
-          </a:p>
-          <a:p>
-            <a:pPr>
-              <a:spcBef>
-                <a:spcPts val="1000"/>
-              </a:spcBef>
-              <a:defRPr sz="2000"/>
-            </a:pPr>
-            <a:r>
-              <a:t>Gestión: Scorecard unificado y visibilidad ejecutiva.</a:t>
+              <a:t>Sostenibilidad de la plataforma.</a:t>
             </a:r>
           </a:p>
         </p:txBody>
       </p:sp>
       <p:pic>
         <p:nvPicPr>
-          <p:cNvPr id="4" name="Picture 3" descr="visual_1_D.png"/>
+          <p:cNvPr id="4" name="Picture 3" descr="ppt1_slide7.png"/>
           <p:cNvPicPr>
             <a:picLocks noChangeAspect="1"/>
           </p:cNvPicPr>
@@ -4039,8 +3991,8 @@
         </p:blipFill>
         <p:spPr>
           <a:xfrm>
-            <a:off x="4572000" y="2881118"/>
-            <a:ext cx="4114800" cy="2010164"/>
+            <a:off x="4114800" y="2554889"/>
+            <a:ext cx="4572000" cy="2662621"/>
           </a:xfrm>
           <a:prstGeom prst="rect">
             <a:avLst/>

</xml_diff>

<commit_message>
docs: upgrade PPT design with Widescreen format, bigger images, and corporate styling
</commit_message>
<xml_diff>
--- a/reference/governance/sdlc/assets/evolith-sdlc-executive-deck.pptx
+++ b/reference/governance/sdlc/assets/evolith-sdlc-executive-deck.pptx
@@ -14,7 +14,7 @@
     <p:sldId id="262" r:id="rId13"/>
     <p:sldId id="263" r:id="rId14"/>
   </p:sldIdLst>
-  <p:sldSz cx="9144000" cy="6858000" type="screen4x3"/>
+  <p:sldSz cx="12191695" cy="6858000" type="screen4x3"/>
   <p:notesSz cx="6858000" cy="9144000"/>
   <p:defaultTextStyle>
     <a:defPPr>
@@ -3088,14 +3088,6 @@
 <file path=ppt/slides/slide1.xml><?xml version="1.0" encoding="utf-8"?>
 <p:sld xmlns:a="http://schemas.openxmlformats.org/drawingml/2006/main" xmlns:p="http://schemas.openxmlformats.org/presentationml/2006/main" xmlns:r="http://schemas.openxmlformats.org/officeDocument/2006/relationships">
   <p:cSld>
-    <p:bg>
-      <p:bgPr>
-        <a:solidFill>
-          <a:srgbClr val="1E3A5F"/>
-        </a:solidFill>
-        <a:effectLst/>
-      </p:bgPr>
-    </p:bg>
     <p:spTree>
       <p:nvGrpSpPr>
         <p:cNvPr id="1" name=""/>
@@ -3105,21 +3097,118 @@
       <p:grpSpPr/>
       <p:sp>
         <p:nvSpPr>
-          <p:cNvPr id="2" name="Title 1"/>
-          <p:cNvSpPr>
-            <a:spLocks noGrp="1"/>
-          </p:cNvSpPr>
-          <p:nvPr>
-            <p:ph type="ctrTitle"/>
-          </p:nvPr>
-        </p:nvSpPr>
-        <p:spPr/>
-        <p:txBody>
-          <a:bodyPr/>
+          <p:cNvPr id="2" name="Rectangle 1"/>
+          <p:cNvSpPr/>
+          <p:nvPr/>
+        </p:nvSpPr>
+        <p:spPr>
+          <a:xfrm>
+            <a:off x="0" y="0"/>
+            <a:ext cx="12191695" cy="6858000"/>
+          </a:xfrm>
+          <a:prstGeom prst="rect">
+            <a:avLst/>
+          </a:prstGeom>
+          <a:solidFill>
+            <a:srgbClr val="1E3A5F"/>
+          </a:solidFill>
+          <a:ln>
+            <a:solidFill>
+              <a:srgbClr val="1E3A5F"/>
+            </a:solidFill>
+          </a:ln>
+        </p:spPr>
+        <p:style>
+          <a:lnRef idx="1">
+            <a:schemeClr val="accent1"/>
+          </a:lnRef>
+          <a:fillRef idx="3">
+            <a:schemeClr val="accent1"/>
+          </a:fillRef>
+          <a:effectRef idx="2">
+            <a:schemeClr val="accent1"/>
+          </a:effectRef>
+          <a:fontRef idx="minor">
+            <a:schemeClr val="lt1"/>
+          </a:fontRef>
+        </p:style>
+        <p:txBody>
+          <a:bodyPr rtlCol="0" anchor="ctr"/>
+          <a:lstStyle/>
+          <a:p>
+            <a:pPr algn="ctr"/>
+          </a:p>
+        </p:txBody>
+      </p:sp>
+      <p:sp>
+        <p:nvSpPr>
+          <p:cNvPr id="3" name="Rectangle 2"/>
+          <p:cNvSpPr/>
+          <p:nvPr/>
+        </p:nvSpPr>
+        <p:spPr>
+          <a:xfrm>
+            <a:off x="0" y="6400800"/>
+            <a:ext cx="12191695" cy="457200"/>
+          </a:xfrm>
+          <a:prstGeom prst="rect">
+            <a:avLst/>
+          </a:prstGeom>
+          <a:solidFill>
+            <a:srgbClr val="3B82F6"/>
+          </a:solidFill>
+          <a:ln>
+            <a:solidFill>
+              <a:srgbClr val="3B82F6"/>
+            </a:solidFill>
+          </a:ln>
+        </p:spPr>
+        <p:style>
+          <a:lnRef idx="1">
+            <a:schemeClr val="accent1"/>
+          </a:lnRef>
+          <a:fillRef idx="3">
+            <a:schemeClr val="accent1"/>
+          </a:fillRef>
+          <a:effectRef idx="2">
+            <a:schemeClr val="accent1"/>
+          </a:effectRef>
+          <a:fontRef idx="minor">
+            <a:schemeClr val="lt1"/>
+          </a:fontRef>
+        </p:style>
+        <p:txBody>
+          <a:bodyPr rtlCol="0" anchor="ctr"/>
+          <a:lstStyle/>
+          <a:p>
+            <a:pPr algn="ctr"/>
+          </a:p>
+        </p:txBody>
+      </p:sp>
+      <p:sp>
+        <p:nvSpPr>
+          <p:cNvPr id="4" name="TextBox 3"/>
+          <p:cNvSpPr txBox="1"/>
+          <p:nvPr/>
+        </p:nvSpPr>
+        <p:spPr>
+          <a:xfrm>
+            <a:off x="914400" y="2286000"/>
+            <a:ext cx="10362895" cy="1828800"/>
+          </a:xfrm>
+          <a:prstGeom prst="rect">
+            <a:avLst/>
+          </a:prstGeom>
+          <a:noFill/>
+        </p:spPr>
+        <p:txBody>
+          <a:bodyPr wrap="square">
+            <a:spAutoFit/>
+          </a:bodyPr>
           <a:lstStyle/>
           <a:p>
             <a:pPr>
-              <a:defRPr b="1">
+              <a:defRPr b="1" sz="5400">
                 <a:solidFill>
                   <a:srgbClr val="FFFFFF"/>
                 </a:solidFill>
@@ -3129,25 +3218,12 @@
               <a:t>Evolith ARCH32 + SDLC Corporativo</a:t>
             </a:r>
           </a:p>
-        </p:txBody>
-      </p:sp>
-      <p:sp>
-        <p:nvSpPr>
-          <p:cNvPr id="3" name="Subtitle 2"/>
-          <p:cNvSpPr>
-            <a:spLocks noGrp="1"/>
-          </p:cNvSpPr>
-          <p:nvPr>
-            <p:ph type="subTitle" idx="1"/>
-          </p:nvPr>
-        </p:nvSpPr>
-        <p:spPr/>
-        <p:txBody>
-          <a:bodyPr/>
-          <a:lstStyle/>
           <a:p>
             <a:pPr>
-              <a:defRPr>
+              <a:spcBef>
+                <a:spcPts val="1400"/>
+              </a:spcBef>
+              <a:defRPr sz="2800">
                 <a:solidFill>
                   <a:srgbClr val="3B82F6"/>
                 </a:solidFill>
@@ -3179,23 +3255,120 @@
       <p:grpSpPr/>
       <p:sp>
         <p:nvSpPr>
-          <p:cNvPr id="2" name="Title 1"/>
-          <p:cNvSpPr>
-            <a:spLocks noGrp="1"/>
-          </p:cNvSpPr>
-          <p:nvPr>
-            <p:ph type="title"/>
-          </p:nvPr>
-        </p:nvSpPr>
-        <p:spPr/>
-        <p:txBody>
-          <a:bodyPr/>
+          <p:cNvPr id="2" name="Rectangle 1"/>
+          <p:cNvSpPr/>
+          <p:nvPr/>
+        </p:nvSpPr>
+        <p:spPr>
+          <a:xfrm>
+            <a:off x="0" y="0"/>
+            <a:ext cx="12191695" cy="1097280"/>
+          </a:xfrm>
+          <a:prstGeom prst="rect">
+            <a:avLst/>
+          </a:prstGeom>
+          <a:solidFill>
+            <a:srgbClr val="1E3A5F"/>
+          </a:solidFill>
+          <a:ln>
+            <a:solidFill>
+              <a:srgbClr val="1E3A5F"/>
+            </a:solidFill>
+          </a:ln>
+        </p:spPr>
+        <p:style>
+          <a:lnRef idx="1">
+            <a:schemeClr val="accent1"/>
+          </a:lnRef>
+          <a:fillRef idx="3">
+            <a:schemeClr val="accent1"/>
+          </a:fillRef>
+          <a:effectRef idx="2">
+            <a:schemeClr val="accent1"/>
+          </a:effectRef>
+          <a:fontRef idx="minor">
+            <a:schemeClr val="lt1"/>
+          </a:fontRef>
+        </p:style>
+        <p:txBody>
+          <a:bodyPr rtlCol="0" anchor="ctr"/>
+          <a:lstStyle/>
+          <a:p>
+            <a:pPr algn="ctr"/>
+          </a:p>
+        </p:txBody>
+      </p:sp>
+      <p:sp>
+        <p:nvSpPr>
+          <p:cNvPr id="3" name="Rectangle 2"/>
+          <p:cNvSpPr/>
+          <p:nvPr/>
+        </p:nvSpPr>
+        <p:spPr>
+          <a:xfrm>
+            <a:off x="0" y="1097280"/>
+            <a:ext cx="12191695" cy="91440"/>
+          </a:xfrm>
+          <a:prstGeom prst="rect">
+            <a:avLst/>
+          </a:prstGeom>
+          <a:solidFill>
+            <a:srgbClr val="3B82F6"/>
+          </a:solidFill>
+          <a:ln>
+            <a:solidFill>
+              <a:srgbClr val="3B82F6"/>
+            </a:solidFill>
+          </a:ln>
+        </p:spPr>
+        <p:style>
+          <a:lnRef idx="1">
+            <a:schemeClr val="accent1"/>
+          </a:lnRef>
+          <a:fillRef idx="3">
+            <a:schemeClr val="accent1"/>
+          </a:fillRef>
+          <a:effectRef idx="2">
+            <a:schemeClr val="accent1"/>
+          </a:effectRef>
+          <a:fontRef idx="minor">
+            <a:schemeClr val="lt1"/>
+          </a:fontRef>
+        </p:style>
+        <p:txBody>
+          <a:bodyPr rtlCol="0" anchor="ctr"/>
+          <a:lstStyle/>
+          <a:p>
+            <a:pPr algn="ctr"/>
+          </a:p>
+        </p:txBody>
+      </p:sp>
+      <p:sp>
+        <p:nvSpPr>
+          <p:cNvPr id="4" name="TextBox 3"/>
+          <p:cNvSpPr txBox="1"/>
+          <p:nvPr/>
+        </p:nvSpPr>
+        <p:spPr>
+          <a:xfrm>
+            <a:off x="457200" y="91440"/>
+            <a:ext cx="11277295" cy="914400"/>
+          </a:xfrm>
+          <a:prstGeom prst="rect">
+            <a:avLst/>
+          </a:prstGeom>
+          <a:noFill/>
+        </p:spPr>
+        <p:txBody>
+          <a:bodyPr wrap="none">
+            <a:spAutoFit/>
+          </a:bodyPr>
           <a:lstStyle/>
           <a:p>
             <a:pPr>
-              <a:defRPr>
+              <a:defRPr b="1" sz="3600">
                 <a:solidFill>
-                  <a:srgbClr val="1E3A5F"/>
+                  <a:srgbClr val="FFFFFF"/>
                 </a:solidFill>
               </a:defRPr>
             </a:pPr>
@@ -3207,25 +3380,32 @@
       </p:sp>
       <p:sp>
         <p:nvSpPr>
-          <p:cNvPr id="3" name="Content Placeholder 2"/>
-          <p:cNvSpPr>
-            <a:spLocks noGrp="1"/>
-          </p:cNvSpPr>
-          <p:nvPr>
-            <p:ph idx="1"/>
-          </p:nvPr>
-        </p:nvSpPr>
-        <p:spPr>
-          <a:xfrm>
-            <a:ext cx="3840480" cy="0"/>
-          </a:xfrm>
-        </p:spPr>
-        <p:txBody>
-          <a:bodyPr/>
+          <p:cNvPr id="5" name="TextBox 4"/>
+          <p:cNvSpPr txBox="1"/>
+          <p:nvPr/>
+        </p:nvSpPr>
+        <p:spPr>
+          <a:xfrm>
+            <a:off x="457200" y="1645920"/>
+            <a:ext cx="4114800" cy="4572000"/>
+          </a:xfrm>
+          <a:prstGeom prst="rect">
+            <a:avLst/>
+          </a:prstGeom>
+          <a:noFill/>
+        </p:spPr>
+        <p:txBody>
+          <a:bodyPr wrap="square">
+            <a:spAutoFit/>
+          </a:bodyPr>
           <a:lstStyle/>
           <a:p>
             <a:pPr>
-              <a:defRPr sz="1800"/>
+              <a:defRPr sz="2200">
+                <a:solidFill>
+                  <a:srgbClr val="323232"/>
+                </a:solidFill>
+              </a:defRPr>
             </a:pPr>
             <a:r>
               <a:t>Framework corporativo y arquitectura base.</a:t>
@@ -3234,30 +3414,38 @@
           <a:p>
             <a:pPr>
               <a:spcBef>
-                <a:spcPts val="800"/>
+                <a:spcPts val="1400"/>
               </a:spcBef>
-              <a:defRPr sz="1800"/>
+              <a:defRPr sz="2200">
+                <a:solidFill>
+                  <a:srgbClr val="323232"/>
+                </a:solidFill>
+              </a:defRPr>
             </a:pPr>
             <a:r>
-              <a:t>Estandariza patrones entre equipos.</a:t>
+              <a:t>• Estandariza patrones entre equipos.</a:t>
             </a:r>
           </a:p>
           <a:p>
             <a:pPr>
               <a:spcBef>
-                <a:spcPts val="800"/>
+                <a:spcPts val="1400"/>
               </a:spcBef>
-              <a:defRPr sz="1800"/>
+              <a:defRPr sz="2200">
+                <a:solidFill>
+                  <a:srgbClr val="323232"/>
+                </a:solidFill>
+              </a:defRPr>
             </a:pPr>
             <a:r>
-              <a:t>No es una app, es el modelo operativo.</a:t>
+              <a:t>• No es una app, es el modelo operativo.</a:t>
             </a:r>
           </a:p>
         </p:txBody>
       </p:sp>
       <p:pic>
         <p:nvPicPr>
-          <p:cNvPr id="4" name="Picture 3" descr="ppt1_slide1.png"/>
+          <p:cNvPr id="6" name="Picture 5" descr="ppt1_slide1.png"/>
           <p:cNvPicPr>
             <a:picLocks noChangeAspect="1"/>
           </p:cNvPicPr>
@@ -3271,8 +3459,8 @@
         </p:blipFill>
         <p:spPr>
           <a:xfrm>
-            <a:off x="4114800" y="3343548"/>
-            <a:ext cx="4572000" cy="1085304"/>
+            <a:off x="5029200" y="1645920"/>
+            <a:ext cx="6583680" cy="1562838"/>
           </a:xfrm>
           <a:prstGeom prst="rect">
             <a:avLst/>
@@ -3299,23 +3487,120 @@
       <p:grpSpPr/>
       <p:sp>
         <p:nvSpPr>
-          <p:cNvPr id="2" name="Title 1"/>
-          <p:cNvSpPr>
-            <a:spLocks noGrp="1"/>
-          </p:cNvSpPr>
-          <p:nvPr>
-            <p:ph type="title"/>
-          </p:nvPr>
-        </p:nvSpPr>
-        <p:spPr/>
-        <p:txBody>
-          <a:bodyPr/>
+          <p:cNvPr id="2" name="Rectangle 1"/>
+          <p:cNvSpPr/>
+          <p:nvPr/>
+        </p:nvSpPr>
+        <p:spPr>
+          <a:xfrm>
+            <a:off x="0" y="0"/>
+            <a:ext cx="12191695" cy="1097280"/>
+          </a:xfrm>
+          <a:prstGeom prst="rect">
+            <a:avLst/>
+          </a:prstGeom>
+          <a:solidFill>
+            <a:srgbClr val="1E3A5F"/>
+          </a:solidFill>
+          <a:ln>
+            <a:solidFill>
+              <a:srgbClr val="1E3A5F"/>
+            </a:solidFill>
+          </a:ln>
+        </p:spPr>
+        <p:style>
+          <a:lnRef idx="1">
+            <a:schemeClr val="accent1"/>
+          </a:lnRef>
+          <a:fillRef idx="3">
+            <a:schemeClr val="accent1"/>
+          </a:fillRef>
+          <a:effectRef idx="2">
+            <a:schemeClr val="accent1"/>
+          </a:effectRef>
+          <a:fontRef idx="minor">
+            <a:schemeClr val="lt1"/>
+          </a:fontRef>
+        </p:style>
+        <p:txBody>
+          <a:bodyPr rtlCol="0" anchor="ctr"/>
+          <a:lstStyle/>
+          <a:p>
+            <a:pPr algn="ctr"/>
+          </a:p>
+        </p:txBody>
+      </p:sp>
+      <p:sp>
+        <p:nvSpPr>
+          <p:cNvPr id="3" name="Rectangle 2"/>
+          <p:cNvSpPr/>
+          <p:nvPr/>
+        </p:nvSpPr>
+        <p:spPr>
+          <a:xfrm>
+            <a:off x="0" y="1097280"/>
+            <a:ext cx="12191695" cy="91440"/>
+          </a:xfrm>
+          <a:prstGeom prst="rect">
+            <a:avLst/>
+          </a:prstGeom>
+          <a:solidFill>
+            <a:srgbClr val="3B82F6"/>
+          </a:solidFill>
+          <a:ln>
+            <a:solidFill>
+              <a:srgbClr val="3B82F6"/>
+            </a:solidFill>
+          </a:ln>
+        </p:spPr>
+        <p:style>
+          <a:lnRef idx="1">
+            <a:schemeClr val="accent1"/>
+          </a:lnRef>
+          <a:fillRef idx="3">
+            <a:schemeClr val="accent1"/>
+          </a:fillRef>
+          <a:effectRef idx="2">
+            <a:schemeClr val="accent1"/>
+          </a:effectRef>
+          <a:fontRef idx="minor">
+            <a:schemeClr val="lt1"/>
+          </a:fontRef>
+        </p:style>
+        <p:txBody>
+          <a:bodyPr rtlCol="0" anchor="ctr"/>
+          <a:lstStyle/>
+          <a:p>
+            <a:pPr algn="ctr"/>
+          </a:p>
+        </p:txBody>
+      </p:sp>
+      <p:sp>
+        <p:nvSpPr>
+          <p:cNvPr id="4" name="TextBox 3"/>
+          <p:cNvSpPr txBox="1"/>
+          <p:nvPr/>
+        </p:nvSpPr>
+        <p:spPr>
+          <a:xfrm>
+            <a:off x="457200" y="91440"/>
+            <a:ext cx="11277295" cy="914400"/>
+          </a:xfrm>
+          <a:prstGeom prst="rect">
+            <a:avLst/>
+          </a:prstGeom>
+          <a:noFill/>
+        </p:spPr>
+        <p:txBody>
+          <a:bodyPr wrap="none">
+            <a:spAutoFit/>
+          </a:bodyPr>
           <a:lstStyle/>
           <a:p>
             <a:pPr>
-              <a:defRPr>
+              <a:defRPr b="1" sz="3600">
                 <a:solidFill>
-                  <a:srgbClr val="1E3A5F"/>
+                  <a:srgbClr val="FFFFFF"/>
                 </a:solidFill>
               </a:defRPr>
             </a:pPr>
@@ -3327,25 +3612,32 @@
       </p:sp>
       <p:sp>
         <p:nvSpPr>
-          <p:cNvPr id="3" name="Content Placeholder 2"/>
-          <p:cNvSpPr>
-            <a:spLocks noGrp="1"/>
-          </p:cNvSpPr>
-          <p:nvPr>
-            <p:ph idx="1"/>
-          </p:nvPr>
-        </p:nvSpPr>
-        <p:spPr>
-          <a:xfrm>
-            <a:ext cx="3840480" cy="0"/>
-          </a:xfrm>
-        </p:spPr>
-        <p:txBody>
-          <a:bodyPr/>
+          <p:cNvPr id="5" name="TextBox 4"/>
+          <p:cNvSpPr txBox="1"/>
+          <p:nvPr/>
+        </p:nvSpPr>
+        <p:spPr>
+          <a:xfrm>
+            <a:off x="457200" y="1645920"/>
+            <a:ext cx="4114800" cy="4572000"/>
+          </a:xfrm>
+          <a:prstGeom prst="rect">
+            <a:avLst/>
+          </a:prstGeom>
+          <a:noFill/>
+        </p:spPr>
+        <p:txBody>
+          <a:bodyPr wrap="square">
+            <a:spAutoFit/>
+          </a:bodyPr>
           <a:lstStyle/>
           <a:p>
             <a:pPr>
-              <a:defRPr sz="1800"/>
+              <a:defRPr sz="2200">
+                <a:solidFill>
+                  <a:srgbClr val="323232"/>
+                </a:solidFill>
+              </a:defRPr>
             </a:pPr>
             <a:r>
               <a:t>Elimina zonas grises y deuda técnica silenciosa.</a:t>
@@ -3354,30 +3646,38 @@
           <a:p>
             <a:pPr>
               <a:spcBef>
-                <a:spcPts val="800"/>
+                <a:spcPts val="1400"/>
               </a:spcBef>
-              <a:defRPr sz="1800"/>
+              <a:defRPr sz="2200">
+                <a:solidFill>
+                  <a:srgbClr val="323232"/>
+                </a:solidFill>
+              </a:defRPr>
             </a:pPr>
             <a:r>
-              <a:t>Previene arquitectura fragmentada.</a:t>
+              <a:t>• Previene arquitectura fragmentada.</a:t>
             </a:r>
           </a:p>
           <a:p>
             <a:pPr>
               <a:spcBef>
-                <a:spcPts val="800"/>
+                <a:spcPts val="1400"/>
               </a:spcBef>
-              <a:defRPr sz="1800"/>
+              <a:defRPr sz="2200">
+                <a:solidFill>
+                  <a:srgbClr val="323232"/>
+                </a:solidFill>
+              </a:defRPr>
             </a:pPr>
             <a:r>
-              <a:t>Reduce el riesgo de delivery.</a:t>
+              <a:t>• Reduce el riesgo de delivery.</a:t>
             </a:r>
           </a:p>
         </p:txBody>
       </p:sp>
       <p:pic>
         <p:nvPicPr>
-          <p:cNvPr id="4" name="Picture 3" descr="ppt1_slide2.png"/>
+          <p:cNvPr id="6" name="Picture 5" descr="ppt1_slide2.png"/>
           <p:cNvPicPr>
             <a:picLocks noChangeAspect="1"/>
           </p:cNvPicPr>
@@ -3391,8 +3691,8 @@
         </p:blipFill>
         <p:spPr>
           <a:xfrm>
-            <a:off x="4114800" y="3168214"/>
-            <a:ext cx="4572000" cy="1435971"/>
+            <a:off x="5029200" y="1645920"/>
+            <a:ext cx="6583680" cy="2067798"/>
           </a:xfrm>
           <a:prstGeom prst="rect">
             <a:avLst/>
@@ -3419,23 +3719,120 @@
       <p:grpSpPr/>
       <p:sp>
         <p:nvSpPr>
-          <p:cNvPr id="2" name="Title 1"/>
-          <p:cNvSpPr>
-            <a:spLocks noGrp="1"/>
-          </p:cNvSpPr>
-          <p:nvPr>
-            <p:ph type="title"/>
-          </p:nvPr>
-        </p:nvSpPr>
-        <p:spPr/>
-        <p:txBody>
-          <a:bodyPr/>
+          <p:cNvPr id="2" name="Rectangle 1"/>
+          <p:cNvSpPr/>
+          <p:nvPr/>
+        </p:nvSpPr>
+        <p:spPr>
+          <a:xfrm>
+            <a:off x="0" y="0"/>
+            <a:ext cx="12191695" cy="1097280"/>
+          </a:xfrm>
+          <a:prstGeom prst="rect">
+            <a:avLst/>
+          </a:prstGeom>
+          <a:solidFill>
+            <a:srgbClr val="1E3A5F"/>
+          </a:solidFill>
+          <a:ln>
+            <a:solidFill>
+              <a:srgbClr val="1E3A5F"/>
+            </a:solidFill>
+          </a:ln>
+        </p:spPr>
+        <p:style>
+          <a:lnRef idx="1">
+            <a:schemeClr val="accent1"/>
+          </a:lnRef>
+          <a:fillRef idx="3">
+            <a:schemeClr val="accent1"/>
+          </a:fillRef>
+          <a:effectRef idx="2">
+            <a:schemeClr val="accent1"/>
+          </a:effectRef>
+          <a:fontRef idx="minor">
+            <a:schemeClr val="lt1"/>
+          </a:fontRef>
+        </p:style>
+        <p:txBody>
+          <a:bodyPr rtlCol="0" anchor="ctr"/>
+          <a:lstStyle/>
+          <a:p>
+            <a:pPr algn="ctr"/>
+          </a:p>
+        </p:txBody>
+      </p:sp>
+      <p:sp>
+        <p:nvSpPr>
+          <p:cNvPr id="3" name="Rectangle 2"/>
+          <p:cNvSpPr/>
+          <p:nvPr/>
+        </p:nvSpPr>
+        <p:spPr>
+          <a:xfrm>
+            <a:off x="0" y="1097280"/>
+            <a:ext cx="12191695" cy="91440"/>
+          </a:xfrm>
+          <a:prstGeom prst="rect">
+            <a:avLst/>
+          </a:prstGeom>
+          <a:solidFill>
+            <a:srgbClr val="3B82F6"/>
+          </a:solidFill>
+          <a:ln>
+            <a:solidFill>
+              <a:srgbClr val="3B82F6"/>
+            </a:solidFill>
+          </a:ln>
+        </p:spPr>
+        <p:style>
+          <a:lnRef idx="1">
+            <a:schemeClr val="accent1"/>
+          </a:lnRef>
+          <a:fillRef idx="3">
+            <a:schemeClr val="accent1"/>
+          </a:fillRef>
+          <a:effectRef idx="2">
+            <a:schemeClr val="accent1"/>
+          </a:effectRef>
+          <a:fontRef idx="minor">
+            <a:schemeClr val="lt1"/>
+          </a:fontRef>
+        </p:style>
+        <p:txBody>
+          <a:bodyPr rtlCol="0" anchor="ctr"/>
+          <a:lstStyle/>
+          <a:p>
+            <a:pPr algn="ctr"/>
+          </a:p>
+        </p:txBody>
+      </p:sp>
+      <p:sp>
+        <p:nvSpPr>
+          <p:cNvPr id="4" name="TextBox 3"/>
+          <p:cNvSpPr txBox="1"/>
+          <p:nvPr/>
+        </p:nvSpPr>
+        <p:spPr>
+          <a:xfrm>
+            <a:off x="457200" y="91440"/>
+            <a:ext cx="11277295" cy="914400"/>
+          </a:xfrm>
+          <a:prstGeom prst="rect">
+            <a:avLst/>
+          </a:prstGeom>
+          <a:noFill/>
+        </p:spPr>
+        <p:txBody>
+          <a:bodyPr wrap="none">
+            <a:spAutoFit/>
+          </a:bodyPr>
           <a:lstStyle/>
           <a:p>
             <a:pPr>
-              <a:defRPr>
+              <a:defRPr b="1" sz="3600">
                 <a:solidFill>
-                  <a:srgbClr val="1E3A5F"/>
+                  <a:srgbClr val="FFFFFF"/>
                 </a:solidFill>
               </a:defRPr>
             </a:pPr>
@@ -3447,25 +3844,32 @@
       </p:sp>
       <p:sp>
         <p:nvSpPr>
-          <p:cNvPr id="3" name="Content Placeholder 2"/>
-          <p:cNvSpPr>
-            <a:spLocks noGrp="1"/>
-          </p:cNvSpPr>
-          <p:nvPr>
-            <p:ph idx="1"/>
-          </p:nvPr>
-        </p:nvSpPr>
-        <p:spPr>
-          <a:xfrm>
-            <a:ext cx="3840480" cy="0"/>
-          </a:xfrm>
-        </p:spPr>
-        <p:txBody>
-          <a:bodyPr/>
+          <p:cNvPr id="5" name="TextBox 4"/>
+          <p:cNvSpPr txBox="1"/>
+          <p:nvPr/>
+        </p:nvSpPr>
+        <p:spPr>
+          <a:xfrm>
+            <a:off x="457200" y="1645920"/>
+            <a:ext cx="4114800" cy="4572000"/>
+          </a:xfrm>
+          <a:prstGeom prst="rect">
+            <a:avLst/>
+          </a:prstGeom>
+          <a:noFill/>
+        </p:spPr>
+        <p:txBody>
+          <a:bodyPr wrap="square">
+            <a:spAutoFit/>
+          </a:bodyPr>
           <a:lstStyle/>
           <a:p>
             <a:pPr>
-              <a:defRPr sz="1800"/>
+              <a:defRPr sz="2200">
+                <a:solidFill>
+                  <a:srgbClr val="323232"/>
+                </a:solidFill>
+              </a:defRPr>
             </a:pPr>
             <a:r>
               <a:t>Evolith provee la estructura; SDLC el ciclo de vida.</a:t>
@@ -3474,30 +3878,38 @@
           <a:p>
             <a:pPr>
               <a:spcBef>
-                <a:spcPts val="800"/>
+                <a:spcPts val="1400"/>
               </a:spcBef>
-              <a:defRPr sz="1800"/>
+              <a:defRPr sz="2200">
+                <a:solidFill>
+                  <a:srgbClr val="323232"/>
+                </a:solidFill>
+              </a:defRPr>
             </a:pPr>
             <a:r>
-              <a:t>Consta de 5 Fases gobernadas.</a:t>
+              <a:t>• Consta de 5 Fases gobernadas.</a:t>
             </a:r>
           </a:p>
           <a:p>
             <a:pPr>
               <a:spcBef>
-                <a:spcPts val="800"/>
+                <a:spcPts val="1400"/>
               </a:spcBef>
-              <a:defRPr sz="1800"/>
+              <a:defRPr sz="2200">
+                <a:solidFill>
+                  <a:srgbClr val="323232"/>
+                </a:solidFill>
+              </a:defRPr>
             </a:pPr>
             <a:r>
-              <a:t>Progreso condicionado a evidencia.</a:t>
+              <a:t>• Progreso condicionado a evidencia.</a:t>
             </a:r>
           </a:p>
         </p:txBody>
       </p:sp>
       <p:pic>
         <p:nvPicPr>
-          <p:cNvPr id="4" name="Picture 3" descr="ppt1_slide3.png"/>
+          <p:cNvPr id="6" name="Picture 5" descr="ppt1_slide3.png"/>
           <p:cNvPicPr>
             <a:picLocks noChangeAspect="1"/>
           </p:cNvPicPr>
@@ -3511,8 +3923,8 @@
         </p:blipFill>
         <p:spPr>
           <a:xfrm>
-            <a:off x="4114800" y="3717082"/>
-            <a:ext cx="4572000" cy="338235"/>
+            <a:off x="5029200" y="1645920"/>
+            <a:ext cx="6583680" cy="487058"/>
           </a:xfrm>
           <a:prstGeom prst="rect">
             <a:avLst/>
@@ -3539,23 +3951,120 @@
       <p:grpSpPr/>
       <p:sp>
         <p:nvSpPr>
-          <p:cNvPr id="2" name="Title 1"/>
-          <p:cNvSpPr>
-            <a:spLocks noGrp="1"/>
-          </p:cNvSpPr>
-          <p:nvPr>
-            <p:ph type="title"/>
-          </p:nvPr>
-        </p:nvSpPr>
-        <p:spPr/>
-        <p:txBody>
-          <a:bodyPr/>
+          <p:cNvPr id="2" name="Rectangle 1"/>
+          <p:cNvSpPr/>
+          <p:nvPr/>
+        </p:nvSpPr>
+        <p:spPr>
+          <a:xfrm>
+            <a:off x="0" y="0"/>
+            <a:ext cx="12191695" cy="1097280"/>
+          </a:xfrm>
+          <a:prstGeom prst="rect">
+            <a:avLst/>
+          </a:prstGeom>
+          <a:solidFill>
+            <a:srgbClr val="1E3A5F"/>
+          </a:solidFill>
+          <a:ln>
+            <a:solidFill>
+              <a:srgbClr val="1E3A5F"/>
+            </a:solidFill>
+          </a:ln>
+        </p:spPr>
+        <p:style>
+          <a:lnRef idx="1">
+            <a:schemeClr val="accent1"/>
+          </a:lnRef>
+          <a:fillRef idx="3">
+            <a:schemeClr val="accent1"/>
+          </a:fillRef>
+          <a:effectRef idx="2">
+            <a:schemeClr val="accent1"/>
+          </a:effectRef>
+          <a:fontRef idx="minor">
+            <a:schemeClr val="lt1"/>
+          </a:fontRef>
+        </p:style>
+        <p:txBody>
+          <a:bodyPr rtlCol="0" anchor="ctr"/>
+          <a:lstStyle/>
+          <a:p>
+            <a:pPr algn="ctr"/>
+          </a:p>
+        </p:txBody>
+      </p:sp>
+      <p:sp>
+        <p:nvSpPr>
+          <p:cNvPr id="3" name="Rectangle 2"/>
+          <p:cNvSpPr/>
+          <p:nvPr/>
+        </p:nvSpPr>
+        <p:spPr>
+          <a:xfrm>
+            <a:off x="0" y="1097280"/>
+            <a:ext cx="12191695" cy="91440"/>
+          </a:xfrm>
+          <a:prstGeom prst="rect">
+            <a:avLst/>
+          </a:prstGeom>
+          <a:solidFill>
+            <a:srgbClr val="3B82F6"/>
+          </a:solidFill>
+          <a:ln>
+            <a:solidFill>
+              <a:srgbClr val="3B82F6"/>
+            </a:solidFill>
+          </a:ln>
+        </p:spPr>
+        <p:style>
+          <a:lnRef idx="1">
+            <a:schemeClr val="accent1"/>
+          </a:lnRef>
+          <a:fillRef idx="3">
+            <a:schemeClr val="accent1"/>
+          </a:fillRef>
+          <a:effectRef idx="2">
+            <a:schemeClr val="accent1"/>
+          </a:effectRef>
+          <a:fontRef idx="minor">
+            <a:schemeClr val="lt1"/>
+          </a:fontRef>
+        </p:style>
+        <p:txBody>
+          <a:bodyPr rtlCol="0" anchor="ctr"/>
+          <a:lstStyle/>
+          <a:p>
+            <a:pPr algn="ctr"/>
+          </a:p>
+        </p:txBody>
+      </p:sp>
+      <p:sp>
+        <p:nvSpPr>
+          <p:cNvPr id="4" name="TextBox 3"/>
+          <p:cNvSpPr txBox="1"/>
+          <p:nvPr/>
+        </p:nvSpPr>
+        <p:spPr>
+          <a:xfrm>
+            <a:off x="457200" y="91440"/>
+            <a:ext cx="11277295" cy="914400"/>
+          </a:xfrm>
+          <a:prstGeom prst="rect">
+            <a:avLst/>
+          </a:prstGeom>
+          <a:noFill/>
+        </p:spPr>
+        <p:txBody>
+          <a:bodyPr wrap="none">
+            <a:spAutoFit/>
+          </a:bodyPr>
           <a:lstStyle/>
           <a:p>
             <a:pPr>
-              <a:defRPr>
+              <a:defRPr b="1" sz="3600">
                 <a:solidFill>
-                  <a:srgbClr val="1E3A5F"/>
+                  <a:srgbClr val="FFFFFF"/>
                 </a:solidFill>
               </a:defRPr>
             </a:pPr>
@@ -3567,25 +4076,32 @@
       </p:sp>
       <p:sp>
         <p:nvSpPr>
-          <p:cNvPr id="3" name="Content Placeholder 2"/>
-          <p:cNvSpPr>
-            <a:spLocks noGrp="1"/>
-          </p:cNvSpPr>
-          <p:nvPr>
-            <p:ph idx="1"/>
-          </p:nvPr>
-        </p:nvSpPr>
-        <p:spPr>
-          <a:xfrm>
-            <a:ext cx="3840480" cy="0"/>
-          </a:xfrm>
-        </p:spPr>
-        <p:txBody>
-          <a:bodyPr/>
+          <p:cNvPr id="5" name="TextBox 4"/>
+          <p:cNvSpPr txBox="1"/>
+          <p:nvPr/>
+        </p:nvSpPr>
+        <p:spPr>
+          <a:xfrm>
+            <a:off x="457200" y="1645920"/>
+            <a:ext cx="4114800" cy="4572000"/>
+          </a:xfrm>
+          <a:prstGeom prst="rect">
+            <a:avLst/>
+          </a:prstGeom>
+          <a:noFill/>
+        </p:spPr>
+        <p:txBody>
+          <a:bodyPr wrap="square">
+            <a:spAutoFit/>
+          </a:bodyPr>
           <a:lstStyle/>
           <a:p>
             <a:pPr>
-              <a:defRPr sz="1800"/>
+              <a:defRPr sz="2200">
+                <a:solidFill>
+                  <a:srgbClr val="323232"/>
+                </a:solidFill>
+              </a:defRPr>
             </a:pPr>
             <a:r>
               <a:t>Cada fase exige documentación específica.</a:t>
@@ -3594,30 +4110,38 @@
           <a:p>
             <a:pPr>
               <a:spcBef>
-                <a:spcPts val="800"/>
+                <a:spcPts val="1400"/>
               </a:spcBef>
-              <a:defRPr sz="1800"/>
+              <a:defRPr sz="2200">
+                <a:solidFill>
+                  <a:srgbClr val="323232"/>
+                </a:solidFill>
+              </a:defRPr>
             </a:pPr>
             <a:r>
-              <a:t>Desde el PRD funcional hasta las notas de release.</a:t>
+              <a:t>• Desde el PRD funcional hasta las notas de release.</a:t>
             </a:r>
           </a:p>
           <a:p>
             <a:pPr>
               <a:spcBef>
-                <a:spcPts val="800"/>
+                <a:spcPts val="1400"/>
               </a:spcBef>
-              <a:defRPr sz="1800"/>
+              <a:defRPr sz="2200">
+                <a:solidFill>
+                  <a:srgbClr val="323232"/>
+                </a:solidFill>
+              </a:defRPr>
             </a:pPr>
             <a:r>
-              <a:t>Sin artefacto no hay avance.</a:t>
+              <a:t>• Sin artefacto no hay avance.</a:t>
             </a:r>
           </a:p>
         </p:txBody>
       </p:sp>
       <p:pic>
         <p:nvPicPr>
-          <p:cNvPr id="4" name="Picture 3" descr="ppt1_slide4.png"/>
+          <p:cNvPr id="6" name="Picture 5" descr="ppt1_slide4.png"/>
           <p:cNvPicPr>
             <a:picLocks noChangeAspect="1"/>
           </p:cNvPicPr>
@@ -3631,8 +4155,8 @@
         </p:blipFill>
         <p:spPr>
           <a:xfrm>
-            <a:off x="4114800" y="2418767"/>
-            <a:ext cx="4572000" cy="2934865"/>
+            <a:off x="5029200" y="1645920"/>
+            <a:ext cx="6583680" cy="4226205"/>
           </a:xfrm>
           <a:prstGeom prst="rect">
             <a:avLst/>
@@ -3659,23 +4183,120 @@
       <p:grpSpPr/>
       <p:sp>
         <p:nvSpPr>
-          <p:cNvPr id="2" name="Title 1"/>
-          <p:cNvSpPr>
-            <a:spLocks noGrp="1"/>
-          </p:cNvSpPr>
-          <p:nvPr>
-            <p:ph type="title"/>
-          </p:nvPr>
-        </p:nvSpPr>
-        <p:spPr/>
-        <p:txBody>
-          <a:bodyPr/>
+          <p:cNvPr id="2" name="Rectangle 1"/>
+          <p:cNvSpPr/>
+          <p:nvPr/>
+        </p:nvSpPr>
+        <p:spPr>
+          <a:xfrm>
+            <a:off x="0" y="0"/>
+            <a:ext cx="12191695" cy="1097280"/>
+          </a:xfrm>
+          <a:prstGeom prst="rect">
+            <a:avLst/>
+          </a:prstGeom>
+          <a:solidFill>
+            <a:srgbClr val="1E3A5F"/>
+          </a:solidFill>
+          <a:ln>
+            <a:solidFill>
+              <a:srgbClr val="1E3A5F"/>
+            </a:solidFill>
+          </a:ln>
+        </p:spPr>
+        <p:style>
+          <a:lnRef idx="1">
+            <a:schemeClr val="accent1"/>
+          </a:lnRef>
+          <a:fillRef idx="3">
+            <a:schemeClr val="accent1"/>
+          </a:fillRef>
+          <a:effectRef idx="2">
+            <a:schemeClr val="accent1"/>
+          </a:effectRef>
+          <a:fontRef idx="minor">
+            <a:schemeClr val="lt1"/>
+          </a:fontRef>
+        </p:style>
+        <p:txBody>
+          <a:bodyPr rtlCol="0" anchor="ctr"/>
+          <a:lstStyle/>
+          <a:p>
+            <a:pPr algn="ctr"/>
+          </a:p>
+        </p:txBody>
+      </p:sp>
+      <p:sp>
+        <p:nvSpPr>
+          <p:cNvPr id="3" name="Rectangle 2"/>
+          <p:cNvSpPr/>
+          <p:nvPr/>
+        </p:nvSpPr>
+        <p:spPr>
+          <a:xfrm>
+            <a:off x="0" y="1097280"/>
+            <a:ext cx="12191695" cy="91440"/>
+          </a:xfrm>
+          <a:prstGeom prst="rect">
+            <a:avLst/>
+          </a:prstGeom>
+          <a:solidFill>
+            <a:srgbClr val="3B82F6"/>
+          </a:solidFill>
+          <a:ln>
+            <a:solidFill>
+              <a:srgbClr val="3B82F6"/>
+            </a:solidFill>
+          </a:ln>
+        </p:spPr>
+        <p:style>
+          <a:lnRef idx="1">
+            <a:schemeClr val="accent1"/>
+          </a:lnRef>
+          <a:fillRef idx="3">
+            <a:schemeClr val="accent1"/>
+          </a:fillRef>
+          <a:effectRef idx="2">
+            <a:schemeClr val="accent1"/>
+          </a:effectRef>
+          <a:fontRef idx="minor">
+            <a:schemeClr val="lt1"/>
+          </a:fontRef>
+        </p:style>
+        <p:txBody>
+          <a:bodyPr rtlCol="0" anchor="ctr"/>
+          <a:lstStyle/>
+          <a:p>
+            <a:pPr algn="ctr"/>
+          </a:p>
+        </p:txBody>
+      </p:sp>
+      <p:sp>
+        <p:nvSpPr>
+          <p:cNvPr id="4" name="TextBox 3"/>
+          <p:cNvSpPr txBox="1"/>
+          <p:nvPr/>
+        </p:nvSpPr>
+        <p:spPr>
+          <a:xfrm>
+            <a:off x="457200" y="91440"/>
+            <a:ext cx="11277295" cy="914400"/>
+          </a:xfrm>
+          <a:prstGeom prst="rect">
+            <a:avLst/>
+          </a:prstGeom>
+          <a:noFill/>
+        </p:spPr>
+        <p:txBody>
+          <a:bodyPr wrap="none">
+            <a:spAutoFit/>
+          </a:bodyPr>
           <a:lstStyle/>
           <a:p>
             <a:pPr>
-              <a:defRPr>
+              <a:defRPr b="1" sz="3600">
                 <a:solidFill>
-                  <a:srgbClr val="1E3A5F"/>
+                  <a:srgbClr val="FFFFFF"/>
                 </a:solidFill>
               </a:defRPr>
             </a:pPr>
@@ -3687,25 +4308,32 @@
       </p:sp>
       <p:sp>
         <p:nvSpPr>
-          <p:cNvPr id="3" name="Content Placeholder 2"/>
-          <p:cNvSpPr>
-            <a:spLocks noGrp="1"/>
-          </p:cNvSpPr>
-          <p:nvPr>
-            <p:ph idx="1"/>
-          </p:nvPr>
-        </p:nvSpPr>
-        <p:spPr>
-          <a:xfrm>
-            <a:ext cx="3840480" cy="0"/>
-          </a:xfrm>
-        </p:spPr>
-        <p:txBody>
-          <a:bodyPr/>
+          <p:cNvPr id="5" name="TextBox 4"/>
+          <p:cNvSpPr txBox="1"/>
+          <p:nvPr/>
+        </p:nvSpPr>
+        <p:spPr>
+          <a:xfrm>
+            <a:off x="457200" y="1645920"/>
+            <a:ext cx="4114800" cy="4572000"/>
+          </a:xfrm>
+          <a:prstGeom prst="rect">
+            <a:avLst/>
+          </a:prstGeom>
+          <a:noFill/>
+        </p:spPr>
+        <p:txBody>
+          <a:bodyPr wrap="square">
+            <a:spAutoFit/>
+          </a:bodyPr>
           <a:lstStyle/>
           <a:p>
             <a:pPr>
-              <a:defRPr sz="1800"/>
+              <a:defRPr sz="2200">
+                <a:solidFill>
+                  <a:srgbClr val="323232"/>
+                </a:solidFill>
+              </a:defRPr>
             </a:pPr>
             <a:r>
               <a:t>Responsabilidades claras (RACI).</a:t>
@@ -3714,30 +4342,38 @@
           <a:p>
             <a:pPr>
               <a:spcBef>
-                <a:spcPts val="800"/>
+                <a:spcPts val="1400"/>
               </a:spcBef>
-              <a:defRPr sz="1800"/>
+              <a:defRPr sz="2200">
+                <a:solidFill>
+                  <a:srgbClr val="323232"/>
+                </a:solidFill>
+              </a:defRPr>
             </a:pPr>
             <a:r>
-              <a:t>Product Owner define QUÉ.</a:t>
+              <a:t>• Product Owner define QUÉ.</a:t>
             </a:r>
           </a:p>
           <a:p>
             <a:pPr>
               <a:spcBef>
-                <a:spcPts val="800"/>
+                <a:spcPts val="1400"/>
               </a:spcBef>
-              <a:defRPr sz="1800"/>
+              <a:defRPr sz="2200">
+                <a:solidFill>
+                  <a:srgbClr val="323232"/>
+                </a:solidFill>
+              </a:defRPr>
             </a:pPr>
             <a:r>
-              <a:t>Arquitecto/Tech Lead define CÓMO.</a:t>
+              <a:t>• Arquitecto/Tech Lead define CÓMO.</a:t>
             </a:r>
           </a:p>
         </p:txBody>
       </p:sp>
       <p:pic>
         <p:nvPicPr>
-          <p:cNvPr id="4" name="Picture 3" descr="ppt1_slide5.png"/>
+          <p:cNvPr id="6" name="Picture 5" descr="ppt1_slide5.png"/>
           <p:cNvPicPr>
             <a:picLocks noChangeAspect="1"/>
           </p:cNvPicPr>
@@ -3751,8 +4387,8 @@
         </p:blipFill>
         <p:spPr>
           <a:xfrm>
-            <a:off x="4114800" y="3077935"/>
-            <a:ext cx="4572000" cy="1616529"/>
+            <a:off x="5029200" y="1645920"/>
+            <a:ext cx="6583680" cy="2327801"/>
           </a:xfrm>
           <a:prstGeom prst="rect">
             <a:avLst/>
@@ -3779,23 +4415,120 @@
       <p:grpSpPr/>
       <p:sp>
         <p:nvSpPr>
-          <p:cNvPr id="2" name="Title 1"/>
-          <p:cNvSpPr>
-            <a:spLocks noGrp="1"/>
-          </p:cNvSpPr>
-          <p:nvPr>
-            <p:ph type="title"/>
-          </p:nvPr>
-        </p:nvSpPr>
-        <p:spPr/>
-        <p:txBody>
-          <a:bodyPr/>
+          <p:cNvPr id="2" name="Rectangle 1"/>
+          <p:cNvSpPr/>
+          <p:nvPr/>
+        </p:nvSpPr>
+        <p:spPr>
+          <a:xfrm>
+            <a:off x="0" y="0"/>
+            <a:ext cx="12191695" cy="1097280"/>
+          </a:xfrm>
+          <a:prstGeom prst="rect">
+            <a:avLst/>
+          </a:prstGeom>
+          <a:solidFill>
+            <a:srgbClr val="1E3A5F"/>
+          </a:solidFill>
+          <a:ln>
+            <a:solidFill>
+              <a:srgbClr val="1E3A5F"/>
+            </a:solidFill>
+          </a:ln>
+        </p:spPr>
+        <p:style>
+          <a:lnRef idx="1">
+            <a:schemeClr val="accent1"/>
+          </a:lnRef>
+          <a:fillRef idx="3">
+            <a:schemeClr val="accent1"/>
+          </a:fillRef>
+          <a:effectRef idx="2">
+            <a:schemeClr val="accent1"/>
+          </a:effectRef>
+          <a:fontRef idx="minor">
+            <a:schemeClr val="lt1"/>
+          </a:fontRef>
+        </p:style>
+        <p:txBody>
+          <a:bodyPr rtlCol="0" anchor="ctr"/>
+          <a:lstStyle/>
+          <a:p>
+            <a:pPr algn="ctr"/>
+          </a:p>
+        </p:txBody>
+      </p:sp>
+      <p:sp>
+        <p:nvSpPr>
+          <p:cNvPr id="3" name="Rectangle 2"/>
+          <p:cNvSpPr/>
+          <p:nvPr/>
+        </p:nvSpPr>
+        <p:spPr>
+          <a:xfrm>
+            <a:off x="0" y="1097280"/>
+            <a:ext cx="12191695" cy="91440"/>
+          </a:xfrm>
+          <a:prstGeom prst="rect">
+            <a:avLst/>
+          </a:prstGeom>
+          <a:solidFill>
+            <a:srgbClr val="3B82F6"/>
+          </a:solidFill>
+          <a:ln>
+            <a:solidFill>
+              <a:srgbClr val="3B82F6"/>
+            </a:solidFill>
+          </a:ln>
+        </p:spPr>
+        <p:style>
+          <a:lnRef idx="1">
+            <a:schemeClr val="accent1"/>
+          </a:lnRef>
+          <a:fillRef idx="3">
+            <a:schemeClr val="accent1"/>
+          </a:fillRef>
+          <a:effectRef idx="2">
+            <a:schemeClr val="accent1"/>
+          </a:effectRef>
+          <a:fontRef idx="minor">
+            <a:schemeClr val="lt1"/>
+          </a:fontRef>
+        </p:style>
+        <p:txBody>
+          <a:bodyPr rtlCol="0" anchor="ctr"/>
+          <a:lstStyle/>
+          <a:p>
+            <a:pPr algn="ctr"/>
+          </a:p>
+        </p:txBody>
+      </p:sp>
+      <p:sp>
+        <p:nvSpPr>
+          <p:cNvPr id="4" name="TextBox 3"/>
+          <p:cNvSpPr txBox="1"/>
+          <p:nvPr/>
+        </p:nvSpPr>
+        <p:spPr>
+          <a:xfrm>
+            <a:off x="457200" y="91440"/>
+            <a:ext cx="11277295" cy="914400"/>
+          </a:xfrm>
+          <a:prstGeom prst="rect">
+            <a:avLst/>
+          </a:prstGeom>
+          <a:noFill/>
+        </p:spPr>
+        <p:txBody>
+          <a:bodyPr wrap="none">
+            <a:spAutoFit/>
+          </a:bodyPr>
           <a:lstStyle/>
           <a:p>
             <a:pPr>
-              <a:defRPr>
+              <a:defRPr b="1" sz="3600">
                 <a:solidFill>
-                  <a:srgbClr val="1E3A5F"/>
+                  <a:srgbClr val="FFFFFF"/>
                 </a:solidFill>
               </a:defRPr>
             </a:pPr>
@@ -3807,25 +4540,32 @@
       </p:sp>
       <p:sp>
         <p:nvSpPr>
-          <p:cNvPr id="3" name="Content Placeholder 2"/>
-          <p:cNvSpPr>
-            <a:spLocks noGrp="1"/>
-          </p:cNvSpPr>
-          <p:nvPr>
-            <p:ph idx="1"/>
-          </p:nvPr>
-        </p:nvSpPr>
-        <p:spPr>
-          <a:xfrm>
-            <a:ext cx="3840480" cy="0"/>
-          </a:xfrm>
-        </p:spPr>
-        <p:txBody>
-          <a:bodyPr/>
+          <p:cNvPr id="5" name="TextBox 4"/>
+          <p:cNvSpPr txBox="1"/>
+          <p:nvPr/>
+        </p:nvSpPr>
+        <p:spPr>
+          <a:xfrm>
+            <a:off x="457200" y="1645920"/>
+            <a:ext cx="4114800" cy="4572000"/>
+          </a:xfrm>
+          <a:prstGeom prst="rect">
+            <a:avLst/>
+          </a:prstGeom>
+          <a:noFill/>
+        </p:spPr>
+        <p:txBody>
+          <a:bodyPr wrap="square">
+            <a:spAutoFit/>
+          </a:bodyPr>
           <a:lstStyle/>
           <a:p>
             <a:pPr>
-              <a:defRPr sz="1800"/>
+              <a:defRPr sz="2200">
+                <a:solidFill>
+                  <a:srgbClr val="323232"/>
+                </a:solidFill>
+              </a:defRPr>
             </a:pPr>
             <a:r>
               <a:t>Verificaciones automatizadas y objetivas.</a:t>
@@ -3834,30 +4574,38 @@
           <a:p>
             <a:pPr>
               <a:spcBef>
-                <a:spcPts val="800"/>
+                <a:spcPts val="1400"/>
               </a:spcBef>
-              <a:defRPr sz="1800"/>
+              <a:defRPr sz="2200">
+                <a:solidFill>
+                  <a:srgbClr val="323232"/>
+                </a:solidFill>
+              </a:defRPr>
             </a:pPr>
             <a:r>
-              <a:t>Se detiene el despliegue si falla cobertura o seguridad.</a:t>
+              <a:t>• Se detiene el despliegue si falla cobertura o seguridad.</a:t>
             </a:r>
           </a:p>
           <a:p>
             <a:pPr>
               <a:spcBef>
-                <a:spcPts val="800"/>
+                <a:spcPts val="1400"/>
               </a:spcBef>
-              <a:defRPr sz="1800"/>
+              <a:defRPr sz="2200">
+                <a:solidFill>
+                  <a:srgbClr val="323232"/>
+                </a:solidFill>
+              </a:defRPr>
             </a:pPr>
             <a:r>
-              <a:t>Asegura mantenibilidad a largo plazo.</a:t>
+              <a:t>• Asegura mantenibilidad a largo plazo.</a:t>
             </a:r>
           </a:p>
         </p:txBody>
       </p:sp>
       <p:pic>
         <p:nvPicPr>
-          <p:cNvPr id="4" name="Picture 3" descr="ppt1_slide6.png"/>
+          <p:cNvPr id="6" name="Picture 5" descr="ppt1_slide6.png"/>
           <p:cNvPicPr>
             <a:picLocks noChangeAspect="1"/>
           </p:cNvPicPr>
@@ -3871,8 +4619,8 @@
         </p:blipFill>
         <p:spPr>
           <a:xfrm>
-            <a:off x="4114800" y="1996944"/>
-            <a:ext cx="4572000" cy="3778512"/>
+            <a:off x="5029200" y="1645920"/>
+            <a:ext cx="6583680" cy="5441058"/>
           </a:xfrm>
           <a:prstGeom prst="rect">
             <a:avLst/>
@@ -3899,23 +4647,120 @@
       <p:grpSpPr/>
       <p:sp>
         <p:nvSpPr>
-          <p:cNvPr id="2" name="Title 1"/>
-          <p:cNvSpPr>
-            <a:spLocks noGrp="1"/>
-          </p:cNvSpPr>
-          <p:nvPr>
-            <p:ph type="title"/>
-          </p:nvPr>
-        </p:nvSpPr>
-        <p:spPr/>
-        <p:txBody>
-          <a:bodyPr/>
+          <p:cNvPr id="2" name="Rectangle 1"/>
+          <p:cNvSpPr/>
+          <p:nvPr/>
+        </p:nvSpPr>
+        <p:spPr>
+          <a:xfrm>
+            <a:off x="0" y="0"/>
+            <a:ext cx="12191695" cy="1097280"/>
+          </a:xfrm>
+          <a:prstGeom prst="rect">
+            <a:avLst/>
+          </a:prstGeom>
+          <a:solidFill>
+            <a:srgbClr val="1E3A5F"/>
+          </a:solidFill>
+          <a:ln>
+            <a:solidFill>
+              <a:srgbClr val="1E3A5F"/>
+            </a:solidFill>
+          </a:ln>
+        </p:spPr>
+        <p:style>
+          <a:lnRef idx="1">
+            <a:schemeClr val="accent1"/>
+          </a:lnRef>
+          <a:fillRef idx="3">
+            <a:schemeClr val="accent1"/>
+          </a:fillRef>
+          <a:effectRef idx="2">
+            <a:schemeClr val="accent1"/>
+          </a:effectRef>
+          <a:fontRef idx="minor">
+            <a:schemeClr val="lt1"/>
+          </a:fontRef>
+        </p:style>
+        <p:txBody>
+          <a:bodyPr rtlCol="0" anchor="ctr"/>
+          <a:lstStyle/>
+          <a:p>
+            <a:pPr algn="ctr"/>
+          </a:p>
+        </p:txBody>
+      </p:sp>
+      <p:sp>
+        <p:nvSpPr>
+          <p:cNvPr id="3" name="Rectangle 2"/>
+          <p:cNvSpPr/>
+          <p:nvPr/>
+        </p:nvSpPr>
+        <p:spPr>
+          <a:xfrm>
+            <a:off x="0" y="1097280"/>
+            <a:ext cx="12191695" cy="91440"/>
+          </a:xfrm>
+          <a:prstGeom prst="rect">
+            <a:avLst/>
+          </a:prstGeom>
+          <a:solidFill>
+            <a:srgbClr val="3B82F6"/>
+          </a:solidFill>
+          <a:ln>
+            <a:solidFill>
+              <a:srgbClr val="3B82F6"/>
+            </a:solidFill>
+          </a:ln>
+        </p:spPr>
+        <p:style>
+          <a:lnRef idx="1">
+            <a:schemeClr val="accent1"/>
+          </a:lnRef>
+          <a:fillRef idx="3">
+            <a:schemeClr val="accent1"/>
+          </a:fillRef>
+          <a:effectRef idx="2">
+            <a:schemeClr val="accent1"/>
+          </a:effectRef>
+          <a:fontRef idx="minor">
+            <a:schemeClr val="lt1"/>
+          </a:fontRef>
+        </p:style>
+        <p:txBody>
+          <a:bodyPr rtlCol="0" anchor="ctr"/>
+          <a:lstStyle/>
+          <a:p>
+            <a:pPr algn="ctr"/>
+          </a:p>
+        </p:txBody>
+      </p:sp>
+      <p:sp>
+        <p:nvSpPr>
+          <p:cNvPr id="4" name="TextBox 3"/>
+          <p:cNvSpPr txBox="1"/>
+          <p:nvPr/>
+        </p:nvSpPr>
+        <p:spPr>
+          <a:xfrm>
+            <a:off x="457200" y="91440"/>
+            <a:ext cx="11277295" cy="914400"/>
+          </a:xfrm>
+          <a:prstGeom prst="rect">
+            <a:avLst/>
+          </a:prstGeom>
+          <a:noFill/>
+        </p:spPr>
+        <p:txBody>
+          <a:bodyPr wrap="none">
+            <a:spAutoFit/>
+          </a:bodyPr>
           <a:lstStyle/>
           <a:p>
             <a:pPr>
-              <a:defRPr>
+              <a:defRPr b="1" sz="3600">
                 <a:solidFill>
-                  <a:srgbClr val="1E3A5F"/>
+                  <a:srgbClr val="FFFFFF"/>
                 </a:solidFill>
               </a:defRPr>
             </a:pPr>
@@ -3927,25 +4772,32 @@
       </p:sp>
       <p:sp>
         <p:nvSpPr>
-          <p:cNvPr id="3" name="Content Placeholder 2"/>
-          <p:cNvSpPr>
-            <a:spLocks noGrp="1"/>
-          </p:cNvSpPr>
-          <p:nvPr>
-            <p:ph idx="1"/>
-          </p:nvPr>
-        </p:nvSpPr>
-        <p:spPr>
-          <a:xfrm>
-            <a:ext cx="3840480" cy="0"/>
-          </a:xfrm>
-        </p:spPr>
-        <p:txBody>
-          <a:bodyPr/>
+          <p:cNvPr id="5" name="TextBox 4"/>
+          <p:cNvSpPr txBox="1"/>
+          <p:nvPr/>
+        </p:nvSpPr>
+        <p:spPr>
+          <a:xfrm>
+            <a:off x="457200" y="1645920"/>
+            <a:ext cx="4114800" cy="4572000"/>
+          </a:xfrm>
+          <a:prstGeom prst="rect">
+            <a:avLst/>
+          </a:prstGeom>
+          <a:noFill/>
+        </p:spPr>
+        <p:txBody>
+          <a:bodyPr wrap="square">
+            <a:spAutoFit/>
+          </a:bodyPr>
           <a:lstStyle/>
           <a:p>
             <a:pPr>
-              <a:defRPr sz="1800"/>
+              <a:defRPr sz="2200">
+                <a:solidFill>
+                  <a:srgbClr val="323232"/>
+                </a:solidFill>
+              </a:defRPr>
             </a:pPr>
             <a:r>
               <a:t>Menor fricción entre Dev y Ops.</a:t>
@@ -3954,30 +4806,38 @@
           <a:p>
             <a:pPr>
               <a:spcBef>
-                <a:spcPts val="800"/>
+                <a:spcPts val="1400"/>
               </a:spcBef>
-              <a:defRPr sz="1800"/>
+              <a:defRPr sz="2200">
+                <a:solidFill>
+                  <a:srgbClr val="323232"/>
+                </a:solidFill>
+              </a:defRPr>
             </a:pPr>
             <a:r>
-              <a:t>Predicibilidad de negocio.</a:t>
+              <a:t>• Predicibilidad de negocio.</a:t>
             </a:r>
           </a:p>
           <a:p>
             <a:pPr>
               <a:spcBef>
-                <a:spcPts val="800"/>
+                <a:spcPts val="1400"/>
               </a:spcBef>
-              <a:defRPr sz="1800"/>
+              <a:defRPr sz="2200">
+                <a:solidFill>
+                  <a:srgbClr val="323232"/>
+                </a:solidFill>
+              </a:defRPr>
             </a:pPr>
             <a:r>
-              <a:t>Sostenibilidad de la plataforma.</a:t>
+              <a:t>• Sostenibilidad de la plataforma.</a:t>
             </a:r>
           </a:p>
         </p:txBody>
       </p:sp>
       <p:pic>
         <p:nvPicPr>
-          <p:cNvPr id="4" name="Picture 3" descr="ppt1_slide7.png"/>
+          <p:cNvPr id="6" name="Picture 5" descr="ppt1_slide7.png"/>
           <p:cNvPicPr>
             <a:picLocks noChangeAspect="1"/>
           </p:cNvPicPr>
@@ -3991,8 +4851,8 @@
         </p:blipFill>
         <p:spPr>
           <a:xfrm>
-            <a:off x="4114800" y="2554889"/>
-            <a:ext cx="4572000" cy="2662621"/>
+            <a:off x="5029200" y="1645920"/>
+            <a:ext cx="6583680" cy="3834174"/>
           </a:xfrm>
           <a:prstGeom prst="rect">
             <a:avLst/>

</xml_diff>